<commit_message>
added instructions for gitcreds_set(
</commit_message>
<xml_diff>
--- a/GitHub_Workshop_Wk1.pptx
+++ b/GitHub_Workshop_Wk1.pptx
@@ -236,7 +236,7 @@
           <a:p>
             <a:fld id="{EDF8D736-24B3-4615-9A87-596F0294877F}" type="datetimeFigureOut">
               <a:rPr lang="en-CA" smtClean="0"/>
-              <a:t>2026-03-17</a:t>
+              <a:t>2026-03-19</a:t>
             </a:fld>
             <a:endParaRPr lang="en-CA"/>
           </a:p>
@@ -653,7 +653,7 @@
           <a:p>
             <a:fld id="{CF35CF28-8E72-4CAE-ACE6-94AF86DFDF38}" type="slidenum">
               <a:rPr lang="en-CA" smtClean="0"/>
-              <a:t>18</a:t>
+              <a:t>13</a:t>
             </a:fld>
             <a:endParaRPr lang="en-CA"/>
           </a:p>
@@ -662,7 +662,7 @@
     </p:spTree>
     <p:extLst>
       <p:ext uri="{BB962C8B-B14F-4D97-AF65-F5344CB8AC3E}">
-        <p14:creationId xmlns:p14="http://schemas.microsoft.com/office/powerpoint/2010/main" val="966694406"/>
+        <p14:creationId xmlns:p14="http://schemas.microsoft.com/office/powerpoint/2010/main" val="547421580"/>
       </p:ext>
     </p:extLst>
   </p:cSld>
@@ -737,6 +737,90 @@
           <a:p>
             <a:fld id="{CF35CF28-8E72-4CAE-ACE6-94AF86DFDF38}" type="slidenum">
               <a:rPr lang="en-CA" smtClean="0"/>
+              <a:t>18</a:t>
+            </a:fld>
+            <a:endParaRPr lang="en-CA"/>
+          </a:p>
+        </p:txBody>
+      </p:sp>
+    </p:spTree>
+    <p:extLst>
+      <p:ext uri="{BB962C8B-B14F-4D97-AF65-F5344CB8AC3E}">
+        <p14:creationId xmlns:p14="http://schemas.microsoft.com/office/powerpoint/2010/main" val="966694406"/>
+      </p:ext>
+    </p:extLst>
+  </p:cSld>
+  <p:clrMapOvr>
+    <a:masterClrMapping/>
+  </p:clrMapOvr>
+</p:notes>
+</file>
+
+<file path=ppt/notesSlides/notesSlide4.xml><?xml version="1.0" encoding="utf-8"?>
+<p:notes xmlns:a="http://schemas.openxmlformats.org/drawingml/2006/main" xmlns:r="http://schemas.openxmlformats.org/officeDocument/2006/relationships" xmlns:p="http://schemas.openxmlformats.org/presentationml/2006/main">
+  <p:cSld>
+    <p:spTree>
+      <p:nvGrpSpPr>
+        <p:cNvPr id="1" name=""/>
+        <p:cNvGrpSpPr/>
+        <p:nvPr/>
+      </p:nvGrpSpPr>
+      <p:grpSpPr>
+        <a:xfrm>
+          <a:off x="0" y="0"/>
+          <a:ext cx="0" cy="0"/>
+          <a:chOff x="0" y="0"/>
+          <a:chExt cx="0" cy="0"/>
+        </a:xfrm>
+      </p:grpSpPr>
+      <p:sp>
+        <p:nvSpPr>
+          <p:cNvPr id="2" name="Slide Image Placeholder 1"/>
+          <p:cNvSpPr>
+            <a:spLocks noGrp="1" noRot="1" noChangeAspect="1"/>
+          </p:cNvSpPr>
+          <p:nvPr>
+            <p:ph type="sldImg"/>
+          </p:nvPr>
+        </p:nvSpPr>
+        <p:spPr/>
+      </p:sp>
+      <p:sp>
+        <p:nvSpPr>
+          <p:cNvPr id="3" name="Notes Placeholder 2"/>
+          <p:cNvSpPr>
+            <a:spLocks noGrp="1"/>
+          </p:cNvSpPr>
+          <p:nvPr>
+            <p:ph type="body" idx="1"/>
+          </p:nvPr>
+        </p:nvSpPr>
+        <p:spPr/>
+        <p:txBody>
+          <a:bodyPr/>
+          <a:lstStyle/>
+          <a:p>
+            <a:endParaRPr lang="en-CA" dirty="0"/>
+          </a:p>
+        </p:txBody>
+      </p:sp>
+      <p:sp>
+        <p:nvSpPr>
+          <p:cNvPr id="4" name="Slide Number Placeholder 3"/>
+          <p:cNvSpPr>
+            <a:spLocks noGrp="1"/>
+          </p:cNvSpPr>
+          <p:nvPr>
+            <p:ph type="sldNum" sz="quarter" idx="5"/>
+          </p:nvPr>
+        </p:nvSpPr>
+        <p:spPr/>
+        <p:txBody>
+          <a:bodyPr/>
+          <a:lstStyle/>
+          <a:p>
+            <a:fld id="{CF35CF28-8E72-4CAE-ACE6-94AF86DFDF38}" type="slidenum">
+              <a:rPr lang="en-CA" smtClean="0"/>
               <a:t>22</a:t>
             </a:fld>
             <a:endParaRPr lang="en-CA"/>
@@ -756,7 +840,7 @@
 </p:notes>
 </file>
 
-<file path=ppt/notesSlides/notesSlide4.xml><?xml version="1.0" encoding="utf-8"?>
+<file path=ppt/notesSlides/notesSlide5.xml><?xml version="1.0" encoding="utf-8"?>
 <p:notes xmlns:a="http://schemas.openxmlformats.org/drawingml/2006/main" xmlns:r="http://schemas.openxmlformats.org/officeDocument/2006/relationships" xmlns:p="http://schemas.openxmlformats.org/presentationml/2006/main">
   <p:cSld>
     <p:spTree>
@@ -864,7 +948,7 @@
 </p:notes>
 </file>
 
-<file path=ppt/notesSlides/notesSlide5.xml><?xml version="1.0" encoding="utf-8"?>
+<file path=ppt/notesSlides/notesSlide6.xml><?xml version="1.0" encoding="utf-8"?>
 <p:notes xmlns:a="http://schemas.openxmlformats.org/drawingml/2006/main" xmlns:r="http://schemas.openxmlformats.org/officeDocument/2006/relationships" xmlns:p="http://schemas.openxmlformats.org/presentationml/2006/main">
   <p:cSld>
     <p:spTree>
@@ -972,7 +1056,7 @@
 </p:notes>
 </file>
 
-<file path=ppt/notesSlides/notesSlide6.xml><?xml version="1.0" encoding="utf-8"?>
+<file path=ppt/notesSlides/notesSlide7.xml><?xml version="1.0" encoding="utf-8"?>
 <p:notes xmlns:a="http://schemas.openxmlformats.org/drawingml/2006/main" xmlns:r="http://schemas.openxmlformats.org/officeDocument/2006/relationships" xmlns:p="http://schemas.openxmlformats.org/presentationml/2006/main">
   <p:cSld>
     <p:spTree>
@@ -1059,7 +1143,7 @@
 </p:notes>
 </file>
 
-<file path=ppt/notesSlides/notesSlide7.xml><?xml version="1.0" encoding="utf-8"?>
+<file path=ppt/notesSlides/notesSlide8.xml><?xml version="1.0" encoding="utf-8"?>
 <p:notes xmlns:a="http://schemas.openxmlformats.org/drawingml/2006/main" xmlns:r="http://schemas.openxmlformats.org/officeDocument/2006/relationships" xmlns:p="http://schemas.openxmlformats.org/presentationml/2006/main">
   <p:cSld>
     <p:spTree>
@@ -1380,7 +1464,7 @@
           <a:p>
             <a:fld id="{1568232E-CE54-426E-9648-547DA0CE0D02}" type="datetimeFigureOut">
               <a:rPr lang="en-CA" smtClean="0"/>
-              <a:t>2026-03-17</a:t>
+              <a:t>2026-03-19</a:t>
             </a:fld>
             <a:endParaRPr lang="en-CA"/>
           </a:p>
@@ -1580,7 +1664,7 @@
           <a:p>
             <a:fld id="{1568232E-CE54-426E-9648-547DA0CE0D02}" type="datetimeFigureOut">
               <a:rPr lang="en-CA" smtClean="0"/>
-              <a:t>2026-03-17</a:t>
+              <a:t>2026-03-19</a:t>
             </a:fld>
             <a:endParaRPr lang="en-CA"/>
           </a:p>
@@ -1790,7 +1874,7 @@
           <a:p>
             <a:fld id="{1568232E-CE54-426E-9648-547DA0CE0D02}" type="datetimeFigureOut">
               <a:rPr lang="en-CA" smtClean="0"/>
-              <a:t>2026-03-17</a:t>
+              <a:t>2026-03-19</a:t>
             </a:fld>
             <a:endParaRPr lang="en-CA"/>
           </a:p>
@@ -1990,7 +2074,7 @@
           <a:p>
             <a:fld id="{1568232E-CE54-426E-9648-547DA0CE0D02}" type="datetimeFigureOut">
               <a:rPr lang="en-CA" smtClean="0"/>
-              <a:t>2026-03-17</a:t>
+              <a:t>2026-03-19</a:t>
             </a:fld>
             <a:endParaRPr lang="en-CA"/>
           </a:p>
@@ -2266,7 +2350,7 @@
           <a:p>
             <a:fld id="{1568232E-CE54-426E-9648-547DA0CE0D02}" type="datetimeFigureOut">
               <a:rPr lang="en-CA" smtClean="0"/>
-              <a:t>2026-03-17</a:t>
+              <a:t>2026-03-19</a:t>
             </a:fld>
             <a:endParaRPr lang="en-CA"/>
           </a:p>
@@ -2534,7 +2618,7 @@
           <a:p>
             <a:fld id="{1568232E-CE54-426E-9648-547DA0CE0D02}" type="datetimeFigureOut">
               <a:rPr lang="en-CA" smtClean="0"/>
-              <a:t>2026-03-17</a:t>
+              <a:t>2026-03-19</a:t>
             </a:fld>
             <a:endParaRPr lang="en-CA"/>
           </a:p>
@@ -2949,7 +3033,7 @@
           <a:p>
             <a:fld id="{1568232E-CE54-426E-9648-547DA0CE0D02}" type="datetimeFigureOut">
               <a:rPr lang="en-CA" smtClean="0"/>
-              <a:t>2026-03-17</a:t>
+              <a:t>2026-03-19</a:t>
             </a:fld>
             <a:endParaRPr lang="en-CA"/>
           </a:p>
@@ -3091,7 +3175,7 @@
           <a:p>
             <a:fld id="{1568232E-CE54-426E-9648-547DA0CE0D02}" type="datetimeFigureOut">
               <a:rPr lang="en-CA" smtClean="0"/>
-              <a:t>2026-03-17</a:t>
+              <a:t>2026-03-19</a:t>
             </a:fld>
             <a:endParaRPr lang="en-CA"/>
           </a:p>
@@ -3204,7 +3288,7 @@
           <a:p>
             <a:fld id="{1568232E-CE54-426E-9648-547DA0CE0D02}" type="datetimeFigureOut">
               <a:rPr lang="en-CA" smtClean="0"/>
-              <a:t>2026-03-17</a:t>
+              <a:t>2026-03-19</a:t>
             </a:fld>
             <a:endParaRPr lang="en-CA"/>
           </a:p>
@@ -3517,7 +3601,7 @@
           <a:p>
             <a:fld id="{1568232E-CE54-426E-9648-547DA0CE0D02}" type="datetimeFigureOut">
               <a:rPr lang="en-CA" smtClean="0"/>
-              <a:t>2026-03-17</a:t>
+              <a:t>2026-03-19</a:t>
             </a:fld>
             <a:endParaRPr lang="en-CA"/>
           </a:p>
@@ -3806,7 +3890,7 @@
           <a:p>
             <a:fld id="{1568232E-CE54-426E-9648-547DA0CE0D02}" type="datetimeFigureOut">
               <a:rPr lang="en-CA" smtClean="0"/>
-              <a:t>2026-03-17</a:t>
+              <a:t>2026-03-19</a:t>
             </a:fld>
             <a:endParaRPr lang="en-CA"/>
           </a:p>
@@ -4049,7 +4133,7 @@
           <a:p>
             <a:fld id="{1568232E-CE54-426E-9648-547DA0CE0D02}" type="datetimeFigureOut">
               <a:rPr lang="en-CA" smtClean="0"/>
-              <a:t>2026-03-17</a:t>
+              <a:t>2026-03-19</a:t>
             </a:fld>
             <a:endParaRPr lang="en-CA"/>
           </a:p>
@@ -4537,13 +4621,13 @@
           <a:lstStyle/>
           <a:p>
             <a:r>
-              <a:rPr lang="en-CA" sz="3600" dirty="0"/>
+              <a:rPr lang="en-CA" sz="3200" dirty="0"/>
               <a:t>Jaclyn Aubin</a:t>
             </a:r>
           </a:p>
           <a:p>
             <a:r>
-              <a:rPr lang="en-CA" sz="3600" dirty="0"/>
+              <a:rPr lang="en-CA" sz="3200" dirty="0"/>
               <a:t>March 19, 2026</a:t>
             </a:r>
           </a:p>
@@ -5321,7 +5405,7 @@
           <p:nvPr/>
         </p:nvPicPr>
         <p:blipFill>
-          <a:blip r:embed="rId2"/>
+          <a:blip r:embed="rId3"/>
           <a:stretch>
             <a:fillRect/>
           </a:stretch>

</xml_diff>